<commit_message>
hope i dont push any credentials
</commit_message>
<xml_diff>
--- a/Dora_S_Profile_Final.pptx
+++ b/Dora_S_Profile_Final.pptx
@@ -4379,7 +4379,7 @@
                   <a:srgbClr val="FFFFFF"/>
                 </a:solidFill>
               </a:rPr>
-              <a:t>Senior HR Leader | Strategic HR Practitioner ( Dora S. )</a:t>
+              <a:t>Executive Financial Leader | Strategic Banking Professional</a:t>
             </a:r>
             <a:endParaRPr lang="en-GB" sz="2400" dirty="0">
               <a:latin typeface="Georgia Pro" panose="02040502050405020303" pitchFamily="18" charset="0"/>
@@ -4541,7 +4541,7 @@
                   <a:srgbClr val="FFFFFF"/>
                 </a:solidFill>
               </a:rPr>
-              <a:t>Freelance – </a:t>
+              <a:t>Deputy General Manager – CFO – </a:t>
             </a:r>
             <a:r>
               <a:rPr b="0" sz="1200">
@@ -4549,7 +4549,7 @@
                   <a:srgbClr val="FFFFFF"/>
                 </a:solidFill>
               </a:rPr>
-              <a:t>Founder of a strategic HR consulting firm</a:t>
+              <a:t>Senior Executive at a Digital Banking Institution</a:t>
             </a:r>
           </a:p>
           <a:p>
@@ -4568,7 +4568,7 @@
                   <a:srgbClr val="FFFFFF"/>
                 </a:solidFill>
               </a:rPr>
-              <a:t>Provides strategic advisory in HR transformation, talent development, and organizational design.</a:t>
+              <a:t>Contributed to business strategy and capital planning initiatives.</a:t>
             </a:r>
           </a:p>
           <a:p>
@@ -4587,7 +4587,26 @@
                   <a:srgbClr val="FFFFFF"/>
                 </a:solidFill>
               </a:rPr>
-              <a:t>Leads initiatives for optimizing workforce performance and cultural alignment.</a:t>
+              <a:t>Ensured compliance with national financial regulations.</a:t>
+            </a:r>
+          </a:p>
+          <a:p>
+            <a:pPr/>
+            <a:r>
+              <a:rPr sz="1400">
+                <a:solidFill>
+                  <a:srgbClr val="FFFFFF"/>
+                </a:solidFill>
+              </a:rPr>
+              <a:t>-&gt; </a:t>
+            </a:r>
+            <a:r>
+              <a:rPr sz="1400">
+                <a:solidFill>
+                  <a:srgbClr val="FFFFFF"/>
+                </a:solidFill>
+              </a:rPr>
+              <a:t>Activated as a key member of Executive Management, reporting to the Board.</a:t>
             </a:r>
           </a:p>
         </p:txBody>
@@ -4718,7 +4737,7 @@
                   <a:srgbClr val="FFFFFF"/>
                 </a:solidFill>
               </a:rPr>
-              <a:t>FMCG, Manufacturing, Banking, Consulting</a:t>
+              <a:t>Banking and Financial Services, including Leasing and Insurance</a:t>
             </a:r>
             <a:endParaRPr lang="en-US" sz="1208" dirty="0">
               <a:latin typeface="Prompt" pitchFamily="2" charset="-34"/>
@@ -4773,7 +4792,7 @@
                   <a:srgbClr val="FFFFFF"/>
                 </a:solidFill>
               </a:rPr>
-              <a:t>30+ years of global HR leadership across various industries and geographies.</a:t>
+              <a:t>30+ years in banking, finance, audit, and executive leadership.</a:t>
             </a:r>
             <a:endParaRPr lang="en-US" sz="1208" dirty="0">
               <a:latin typeface="Prompt" pitchFamily="2" charset="-34"/>
@@ -4871,7 +4890,7 @@
                   <a:srgbClr val="FFFFFF"/>
                 </a:solidFill>
               </a:rPr>
-              <a:t>Group HR Director – </a:t>
+              <a:t>Executive Financial Director – </a:t>
             </a:r>
             <a:r>
               <a:rPr b="0" sz="1200">
@@ -4879,7 +4898,7 @@
                   <a:srgbClr val="FFFFFF"/>
                 </a:solidFill>
               </a:rPr>
-              <a:t>Large industrial conglomerate, overseeing HR across multiple entities.</a:t>
+              <a:t>Pivotal Leader in a Digital Bank Launch</a:t>
             </a:r>
           </a:p>
           <a:p>
@@ -4898,7 +4917,7 @@
                   <a:srgbClr val="FFFFFF"/>
                 </a:solidFill>
               </a:rPr>
-              <a:t>Directed HR strategy across several entities, aligning operations with group-wide transformation.</a:t>
+              <a:t>Successfully launched a new digital banking platform.</a:t>
             </a:r>
           </a:p>
           <a:p>
@@ -4917,7 +4936,7 @@
                   <a:srgbClr val="FFFFFF"/>
                 </a:solidFill>
               </a:rPr>
-              <a:t>Negotiated and implemented seven Collective Labor Agreements, ensuring labour harmony.</a:t>
+              <a:t>Managed significant operational budgets up to 80 million EUR.</a:t>
             </a:r>
           </a:p>
           <a:p>
@@ -4936,7 +4955,7 @@
                   <a:srgbClr val="FFFFFF"/>
                 </a:solidFill>
               </a:rPr>
-              <a:t>Designed and rolled out a new Group Compensation &amp; Benefits strategy, enhancing retention.</a:t>
+              <a:t>Coordinated financial, MIS, controlling, and logistics divisions.</a:t>
             </a:r>
           </a:p>
         </p:txBody>
@@ -4974,7 +4993,7 @@
                   <a:srgbClr val="FFFFFF"/>
                 </a:solidFill>
               </a:rPr>
-              <a:t>Senior Regional HR Manager – </a:t>
+              <a:t>Deputy General Manager – </a:t>
             </a:r>
             <a:r>
               <a:rPr b="0" sz="1200">
@@ -4982,7 +5001,7 @@
                   <a:srgbClr val="FFFFFF"/>
                 </a:solidFill>
               </a:rPr>
-              <a:t>Global Fortune 500 manufacturing company</a:t>
+              <a:t>Senior Leader at a Captive Finance and Leasing Group</a:t>
             </a:r>
           </a:p>
           <a:p>
@@ -5001,7 +5020,7 @@
                   <a:srgbClr val="FFFFFF"/>
                 </a:solidFill>
               </a:rPr>
-              <a:t>Progressed through multiple roles, coordinating HR strategy across a region of ten countries.</a:t>
+              <a:t>Managed a group financial strategy and budget of 100 million EUR.</a:t>
             </a:r>
           </a:p>
           <a:p>
@@ -5020,7 +5039,7 @@
                   <a:srgbClr val="FFFFFF"/>
                 </a:solidFill>
               </a:rPr>
-              <a:t>Led HR strategy, workforce transformation, and organizational projects across many countries.</a:t>
+              <a:t>Coordinated accounting and controlling for multiple entities (leasing, bank, insurance).</a:t>
             </a:r>
           </a:p>
           <a:p>
@@ -5039,26 +5058,7 @@
                   <a:srgbClr val="FFFFFF"/>
                 </a:solidFill>
               </a:rPr>
-              <a:t>Served as EMEA Compensation &amp; Benefits Subject Matter Expert, managing annual compensation cycles across several countries.</a:t>
-            </a:r>
-          </a:p>
-          <a:p>
-            <a:pPr/>
-            <a:r>
-              <a:rPr sz="1400">
-                <a:solidFill>
-                  <a:srgbClr val="FFFFFF"/>
-                </a:solidFill>
-              </a:rPr>
-              <a:t>-&gt; </a:t>
-            </a:r>
-            <a:r>
-              <a:rPr sz="1400">
-                <a:solidFill>
-                  <a:srgbClr val="FFFFFF"/>
-                </a:solidFill>
-              </a:rPr>
-              <a:t>Served as EMEA Subject Matter Expert for ORACLE- PeopleSoft &amp; SAP- SuccessFactors</a:t>
+              <a:t>Successfully implemented SAP and cost centers across the group.</a:t>
             </a:r>
           </a:p>
         </p:txBody>
@@ -5096,7 +5096,7 @@
                   <a:srgbClr val="FFFFFF"/>
                 </a:solidFill>
               </a:rPr>
-              <a:t>Group HR Director – </a:t>
+              <a:t>Executive Vice President &amp; Head of Internal Audit – </a:t>
             </a:r>
             <a:r>
               <a:rPr b="0" sz="1200">
@@ -5104,7 +5104,7 @@
                   <a:srgbClr val="FFFFFF"/>
                 </a:solidFill>
               </a:rPr>
-              <a:t>Global dairy industry leader, managing country-wide HR functions.</a:t>
+              <a:t>Strategic Financial Executive at a Regional Banking Group</a:t>
             </a:r>
           </a:p>
           <a:p>
@@ -5123,7 +5123,7 @@
                   <a:srgbClr val="FFFFFF"/>
                 </a:solidFill>
               </a:rPr>
-              <a:t>Led HR integration of ten acquired companies, with 8 factories and multiple commercial teams.</a:t>
+              <a:t>Managed budgets up to 30 million EUR and ensured regulatory compliance.</a:t>
             </a:r>
           </a:p>
           <a:p>
@@ -5142,7 +5142,7 @@
                   <a:srgbClr val="FFFFFF"/>
                 </a:solidFill>
               </a:rPr>
-              <a:t>Managed $40M HR annual budget, contributing to a 14.2% increase in FCF over 5 years.</a:t>
+              <a:t>Successfully issued 5 million EUR subordinated bonds on public markets.</a:t>
             </a:r>
           </a:p>
           <a:p>
@@ -5161,7 +5161,7 @@
                   <a:srgbClr val="FFFFFF"/>
                 </a:solidFill>
               </a:rPr>
-              <a:t>Reduced voluntary turnover from 25.5% to 10% and improved engagement to 82%.</a:t>
+              <a:t>Implemented IFRS9, IFRS16, and a new reporting platform, optimizing financial processes.</a:t>
             </a:r>
           </a:p>
         </p:txBody>
@@ -5221,7 +5221,7 @@
                   <a:srgbClr val="FFFFFF"/>
                 </a:solidFill>
               </a:rPr>
-              <a:t>HR Strategy, Transformation &amp; Policy, Organizational Design &amp; Workforce Optimization</a:t>
+              <a:t>Financial Leadership &amp; Strategy, Regulatory Compliance &amp; Internal Controls</a:t>
             </a:r>
           </a:p>
           <a:p>
@@ -5240,7 +5240,7 @@
                   <a:srgbClr val="FFFFFF"/>
                 </a:solidFill>
               </a:rPr>
-              <a:t>Compensation &amp; Benefits (EMEA SME), Industrial &amp; Employee Relations</a:t>
+              <a:t>Digital Transformation &amp; System Implementation (SAP, IFRS), Audit &amp; Risk Management</a:t>
             </a:r>
           </a:p>
         </p:txBody>

</xml_diff>